<commit_message>
Updated Day 3 documents
</commit_message>
<xml_diff>
--- a/yocto_training_all_session_decks/session_decks/D3S1_Recap.pptx
+++ b/yocto_training_all_session_decks/session_decks/D3S1_Recap.pptx
@@ -5,20 +5,20 @@
     <p:sldMasterId id="2147483648" r:id="rId1"/>
   </p:sldMasterIdLst>
   <p:notesMasterIdLst>
-    <p:notesMasterId r:id="rId8"/>
+    <p:notesMasterId r:id="rId5"/>
   </p:notesMasterIdLst>
   <p:handoutMasterIdLst>
-    <p:handoutMasterId r:id="rId9"/>
+    <p:handoutMasterId r:id="rId6"/>
   </p:handoutMasterIdLst>
   <p:sldIdLst>
-    <p:sldId id="1007" r:id="rId18"/>
-    <p:sldId id="1008" r:id="rId19"/>
-    <p:sldId id="1009" r:id="rId20"/>
+    <p:sldId id="1007" r:id="rId2"/>
+    <p:sldId id="1008" r:id="rId3"/>
+    <p:sldId id="1009" r:id="rId4"/>
   </p:sldIdLst>
   <p:sldSz cx="12192000" cy="6858000"/>
   <p:notesSz cx="6858000" cy="9144000"/>
   <p:custDataLst>
-    <p:tags r:id="rId10"/>
+    <p:tags r:id="rId7"/>
   </p:custDataLst>
   <p:defaultTextStyle>
     <a:defPPr>
@@ -2924,7 +2924,7 @@
           <a:p>
             <a:fld id="{0CEC647C-F50C-4F78-AA33-D7AA6CDA18EE}" type="datetimeFigureOut">
               <a:rPr lang="en-US" smtClean="0"/>
-              <a:t>7/13/2025</a:t>
+              <a:t>6/11/2026</a:t>
             </a:fld>
             <a:endParaRPr lang="en-US"/>
           </a:p>
@@ -3089,7 +3089,7 @@
           <a:p>
             <a:fld id="{3A83341F-E62C-483B-84B4-966F8BE46097}" type="datetimeFigureOut">
               <a:rPr lang="en-US" smtClean="0"/>
-              <a:t>7/13/2025</a:t>
+              <a:t>6/11/2026</a:t>
             </a:fld>
             <a:endParaRPr lang="en-US"/>
           </a:p>
@@ -5173,8 +5173,8 @@
 </p:sldMaster>
 </file>
 
-<file path=ppt/slides/slide7.xml><?xml version="1.0" encoding="utf-8"?>
-<p:sld xmlns:a="http://schemas.openxmlformats.org/drawingml/2006/main" xmlns:p="http://schemas.openxmlformats.org/presentationml/2006/main" xmlns:r="http://schemas.openxmlformats.org/officeDocument/2006/relationships">
+<file path=ppt/slides/slide1.xml><?xml version="1.0" encoding="utf-8"?>
+<p:sld xmlns:a="http://schemas.openxmlformats.org/drawingml/2006/main" xmlns:r="http://schemas.openxmlformats.org/officeDocument/2006/relationships" xmlns:p="http://schemas.openxmlformats.org/presentationml/2006/main">
   <p:cSld>
     <p:spTree>
       <p:nvGrpSpPr>
@@ -5182,7 +5182,14 @@
         <p:cNvGrpSpPr/>
         <p:nvPr/>
       </p:nvGrpSpPr>
-      <p:grpSpPr/>
+      <p:grpSpPr>
+        <a:xfrm>
+          <a:off x="0" y="0"/>
+          <a:ext cx="0" cy="0"/>
+          <a:chOff x="0" y="0"/>
+          <a:chExt cx="0" cy="0"/>
+        </a:xfrm>
+      </p:grpSpPr>
       <p:sp>
         <p:nvSpPr>
           <p:cNvPr id="2" name="Title 1"/>
@@ -5226,18 +5233,7 @@
           <a:lstStyle/>
           <a:p>
             <a:r>
-              <a:rPr sz="2200" i="1">
-                <a:solidFill>
-                  <a:srgbClr val="FFFFFF"/>
-                </a:solidFill>
-                <a:latin typeface="Calibri"/>
-              </a:rPr>
-              <a:t>Day 3 • Session 1 • 15 minutes</a:t>
-            </a:r>
-          </a:p>
-          <a:p>
-            <a:r>
-              <a:rPr sz="1800">
+              <a:rPr sz="1800" dirty="0">
                 <a:solidFill>
                   <a:srgbClr val="FFFFFF"/>
                 </a:solidFill>
@@ -5256,8 +5252,8 @@
 </p:sld>
 </file>
 
-<file path=ppt/slides/slide8.xml><?xml version="1.0" encoding="utf-8"?>
-<p:sld xmlns:a="http://schemas.openxmlformats.org/drawingml/2006/main" xmlns:p="http://schemas.openxmlformats.org/presentationml/2006/main" xmlns:r="http://schemas.openxmlformats.org/officeDocument/2006/relationships">
+<file path=ppt/slides/slide2.xml><?xml version="1.0" encoding="utf-8"?>
+<p:sld xmlns:a="http://schemas.openxmlformats.org/drawingml/2006/main" xmlns:r="http://schemas.openxmlformats.org/officeDocument/2006/relationships" xmlns:p="http://schemas.openxmlformats.org/presentationml/2006/main">
   <p:cSld>
     <p:spTree>
       <p:nvGrpSpPr>
@@ -5265,7 +5261,14 @@
         <p:cNvGrpSpPr/>
         <p:nvPr/>
       </p:nvGrpSpPr>
-      <p:grpSpPr/>
+      <p:grpSpPr>
+        <a:xfrm>
+          <a:off x="0" y="0"/>
+          <a:ext cx="0" cy="0"/>
+          <a:chOff x="0" y="0"/>
+          <a:chExt cx="0" cy="0"/>
+        </a:xfrm>
+      </p:grpSpPr>
       <p:sp>
         <p:nvSpPr>
           <p:cNvPr id="2" name="Title 1"/>
@@ -5282,10 +5285,7 @@
           <a:lstStyle/>
           <a:p>
             <a:r>
-              <a:rPr sz="3200" b="1">
-                <a:solidFill>
-                  <a:srgbClr val="CC0066"/>
-                </a:solidFill>
+              <a:rPr sz="3200" b="1" dirty="0">
                 <a:latin typeface="Calibri"/>
               </a:rPr>
               <a:t>Session Agenda</a:t>
@@ -5388,8 +5388,8 @@
 </p:sld>
 </file>
 
-<file path=ppt/slides/slide9.xml><?xml version="1.0" encoding="utf-8"?>
-<p:sld xmlns:a="http://schemas.openxmlformats.org/drawingml/2006/main" xmlns:p="http://schemas.openxmlformats.org/presentationml/2006/main" xmlns:r="http://schemas.openxmlformats.org/officeDocument/2006/relationships">
+<file path=ppt/slides/slide3.xml><?xml version="1.0" encoding="utf-8"?>
+<p:sld xmlns:a="http://schemas.openxmlformats.org/drawingml/2006/main" xmlns:r="http://schemas.openxmlformats.org/officeDocument/2006/relationships" xmlns:p="http://schemas.openxmlformats.org/presentationml/2006/main">
   <p:cSld>
     <p:spTree>
       <p:nvGrpSpPr>
@@ -5397,7 +5397,14 @@
         <p:cNvGrpSpPr/>
         <p:nvPr/>
       </p:nvGrpSpPr>
-      <p:grpSpPr/>
+      <p:grpSpPr>
+        <a:xfrm>
+          <a:off x="0" y="0"/>
+          <a:ext cx="0" cy="0"/>
+          <a:chOff x="0" y="0"/>
+          <a:chExt cx="0" cy="0"/>
+        </a:xfrm>
+      </p:grpSpPr>
       <p:sp>
         <p:nvSpPr>
           <p:cNvPr id="2" name="Title 1"/>
@@ -5414,10 +5421,7 @@
           <a:lstStyle/>
           <a:p>
             <a:r>
-              <a:rPr sz="3200" b="1">
-                <a:solidFill>
-                  <a:srgbClr val="CC0066"/>
-                </a:solidFill>
+              <a:rPr sz="3200" b="1" dirty="0">
                 <a:latin typeface="Calibri"/>
               </a:rPr>
               <a:t>From Build to Ship</a:t>
@@ -5442,7 +5446,7 @@
           <a:noFill/>
         </p:spPr>
         <p:txBody>
-          <a:bodyPr wrap="square" anchor="t" lIns="45720" rIns="45720">
+          <a:bodyPr wrap="square" lIns="45720" rIns="45720" anchor="t">
             <a:spAutoFit/>
           </a:bodyPr>
           <a:lstStyle/>
@@ -5497,7 +5501,7 @@
           </a:fontRef>
         </p:style>
         <p:txBody>
-          <a:bodyPr rtlCol="0" anchor="ctr" lIns="0" rIns="0"/>
+          <a:bodyPr lIns="0" rIns="0" rtlCol="0" anchor="ctr"/>
           <a:lstStyle/>
           <a:p>
             <a:pPr algn="ctr"/>
@@ -5530,7 +5534,7 @@
           <a:noFill/>
         </p:spPr>
         <p:txBody>
-          <a:bodyPr wrap="square" anchor="t" lIns="45720" rIns="45720">
+          <a:bodyPr wrap="square" lIns="45720" rIns="45720" anchor="t">
             <a:spAutoFit/>
           </a:bodyPr>
           <a:lstStyle/>
@@ -5565,7 +5569,7 @@
           <a:noFill/>
         </p:spPr>
         <p:txBody>
-          <a:bodyPr wrap="square" anchor="t" lIns="45720" rIns="45720">
+          <a:bodyPr wrap="square" lIns="45720" rIns="45720" anchor="t">
             <a:spAutoFit/>
           </a:bodyPr>
           <a:lstStyle/>
@@ -5620,7 +5624,7 @@
           </a:fontRef>
         </p:style>
         <p:txBody>
-          <a:bodyPr rtlCol="0" anchor="ctr" lIns="0" rIns="0"/>
+          <a:bodyPr lIns="0" rIns="0" rtlCol="0" anchor="ctr"/>
           <a:lstStyle/>
           <a:p>
             <a:pPr algn="ctr"/>
@@ -5653,7 +5657,7 @@
           <a:noFill/>
         </p:spPr>
         <p:txBody>
-          <a:bodyPr wrap="square" anchor="t" lIns="45720" rIns="45720">
+          <a:bodyPr wrap="square" lIns="45720" rIns="45720" anchor="t">
             <a:spAutoFit/>
           </a:bodyPr>
           <a:lstStyle/>
@@ -5688,7 +5692,7 @@
           <a:noFill/>
         </p:spPr>
         <p:txBody>
-          <a:bodyPr wrap="square" anchor="t" lIns="45720" rIns="45720">
+          <a:bodyPr wrap="square" lIns="45720" rIns="45720" anchor="t">
             <a:spAutoFit/>
           </a:bodyPr>
           <a:lstStyle/>
@@ -5743,7 +5747,7 @@
           </a:fontRef>
         </p:style>
         <p:txBody>
-          <a:bodyPr rtlCol="0" anchor="ctr" lIns="0" rIns="0"/>
+          <a:bodyPr lIns="0" rIns="0" rtlCol="0" anchor="ctr"/>
           <a:lstStyle/>
           <a:p>
             <a:pPr algn="ctr"/>
@@ -5776,7 +5780,7 @@
           <a:noFill/>
         </p:spPr>
         <p:txBody>
-          <a:bodyPr wrap="square" anchor="t" lIns="45720" rIns="45720">
+          <a:bodyPr wrap="square" lIns="45720" rIns="45720" anchor="t">
             <a:spAutoFit/>
           </a:bodyPr>
           <a:lstStyle/>
@@ -5811,7 +5815,7 @@
           <a:noFill/>
         </p:spPr>
         <p:txBody>
-          <a:bodyPr wrap="square" anchor="t" lIns="45720" rIns="45720">
+          <a:bodyPr wrap="square" lIns="45720" rIns="45720" anchor="t">
             <a:spAutoFit/>
           </a:bodyPr>
           <a:lstStyle/>
@@ -5866,7 +5870,7 @@
           </a:fontRef>
         </p:style>
         <p:txBody>
-          <a:bodyPr rtlCol="0" anchor="ctr" lIns="0" rIns="0"/>
+          <a:bodyPr lIns="0" rIns="0" rtlCol="0" anchor="ctr"/>
           <a:lstStyle/>
           <a:p>
             <a:pPr algn="ctr"/>
@@ -5899,7 +5903,7 @@
           <a:noFill/>
         </p:spPr>
         <p:txBody>
-          <a:bodyPr wrap="square" anchor="t" lIns="45720" rIns="45720">
+          <a:bodyPr wrap="square" lIns="45720" rIns="45720" anchor="t">
             <a:spAutoFit/>
           </a:bodyPr>
           <a:lstStyle/>
@@ -5934,7 +5938,7 @@
           <a:noFill/>
         </p:spPr>
         <p:txBody>
-          <a:bodyPr wrap="square" anchor="t" lIns="45720" rIns="45720">
+          <a:bodyPr wrap="square" lIns="45720" rIns="45720" anchor="t">
             <a:spAutoFit/>
           </a:bodyPr>
           <a:lstStyle/>
@@ -5989,7 +5993,7 @@
           </a:fontRef>
         </p:style>
         <p:txBody>
-          <a:bodyPr rtlCol="0" anchor="ctr" lIns="0" rIns="0"/>
+          <a:bodyPr lIns="0" rIns="0" rtlCol="0" anchor="ctr"/>
           <a:lstStyle/>
           <a:p>
             <a:pPr algn="ctr"/>
@@ -6022,7 +6026,7 @@
           <a:noFill/>
         </p:spPr>
         <p:txBody>
-          <a:bodyPr wrap="square" anchor="t" lIns="45720" rIns="45720">
+          <a:bodyPr wrap="square" lIns="45720" rIns="45720" anchor="t">
             <a:spAutoFit/>
           </a:bodyPr>
           <a:lstStyle/>
@@ -6057,7 +6061,7 @@
           <a:noFill/>
         </p:spPr>
         <p:txBody>
-          <a:bodyPr wrap="square" anchor="t" lIns="45720" rIns="45720">
+          <a:bodyPr wrap="square" lIns="45720" rIns="45720" anchor="t">
             <a:spAutoFit/>
           </a:bodyPr>
           <a:lstStyle/>
@@ -6112,7 +6116,7 @@
           </a:fontRef>
         </p:style>
         <p:txBody>
-          <a:bodyPr rtlCol="0" anchor="ctr" lIns="0" rIns="0"/>
+          <a:bodyPr lIns="0" rIns="0" rtlCol="0" anchor="ctr"/>
           <a:lstStyle/>
           <a:p>
             <a:pPr algn="ctr"/>
@@ -6145,7 +6149,7 @@
           <a:noFill/>
         </p:spPr>
         <p:txBody>
-          <a:bodyPr wrap="square" anchor="t" lIns="45720" rIns="45720">
+          <a:bodyPr wrap="square" lIns="45720" rIns="45720" anchor="t">
             <a:spAutoFit/>
           </a:bodyPr>
           <a:lstStyle/>
@@ -6180,7 +6184,7 @@
           <a:noFill/>
         </p:spPr>
         <p:txBody>
-          <a:bodyPr wrap="square" anchor="t" lIns="45720" rIns="45720">
+          <a:bodyPr wrap="square" lIns="45720" rIns="45720" anchor="t">
             <a:spAutoFit/>
           </a:bodyPr>
           <a:lstStyle/>

</xml_diff>